<commit_message>
Add figures, 3-model worked examples, and deeper comparative analysis
- report.tex: add three_way_compare and transformer cross-attention figures;
  add worked-example section (3 correctors side by side) and a section
  explaining why the attention LSTM and Transformer score so close;
  expand the Bag-of-Words limitations discussion
- presentations (Beamer/reveal/print/pptx): add worked-example and
  why-P4-approx-P5 slides; swap in the three-way length comparison figure;
  expand the Bag-of-Words slide; decks now 17 slides
- DEEP_LEARNING_EXPLAINER: add why-LSTM+attention-approx-Transformer section
</commit_message>
<xml_diff>
--- a/presentation/slides.pptx
+++ b/presentation/slides.pptx
@@ -20,6 +20,8 @@
     <p:sldId id="268" r:id="rId19"/>
     <p:sldId id="269" r:id="rId20"/>
     <p:sldId id="270" r:id="rId21"/>
+    <p:sldId id="271" r:id="rId22"/>
+    <p:sldId id="272" r:id="rId23"/>
   </p:sldIdLst>
   <p:sldSz cx="12191695" cy="6858000" type="screen4x3"/>
   <p:notesSz cx="6858000" cy="9144000"/>
@@ -3266,8 +3268,8 @@
         </p:blipFill>
         <p:spPr>
           <a:xfrm>
-            <a:off x="640080" y="1463040"/>
-            <a:ext cx="3669792" cy="3931920"/>
+            <a:off x="457200" y="1371600"/>
+            <a:ext cx="3157728" cy="3383280"/>
           </a:xfrm>
           <a:prstGeom prst="rect">
             <a:avLst/>
@@ -3290,23 +3292,47 @@
         </p:blipFill>
         <p:spPr>
           <a:xfrm>
-            <a:off x="6400800" y="1463040"/>
-            <a:ext cx="4234375" cy="3931920"/>
+            <a:off x="4297680" y="1371600"/>
+            <a:ext cx="3643532" cy="3383280"/>
           </a:xfrm>
           <a:prstGeom prst="rect">
             <a:avLst/>
           </a:prstGeom>
         </p:spPr>
       </p:pic>
-      <p:sp>
-        <p:nvSpPr>
-          <p:cNvPr id="5" name="TextBox 4"/>
+      <p:pic>
+        <p:nvPicPr>
+          <p:cNvPr id="5" name="Picture 4" descr="dec_cross_attn_3.png"/>
+          <p:cNvPicPr>
+            <a:picLocks noChangeAspect="1"/>
+          </p:cNvPicPr>
+          <p:nvPr/>
+        </p:nvPicPr>
+        <p:blipFill>
+          <a:blip r:embed="rId4"/>
+          <a:stretch>
+            <a:fillRect/>
+          </a:stretch>
+        </p:blipFill>
+        <p:spPr>
+          <a:xfrm>
+            <a:off x="8138160" y="1371600"/>
+            <a:ext cx="3157728" cy="3383280"/>
+          </a:xfrm>
+          <a:prstGeom prst="rect">
+            <a:avLst/>
+          </a:prstGeom>
+        </p:spPr>
+      </p:pic>
+      <p:sp>
+        <p:nvSpPr>
+          <p:cNvPr id="6" name="TextBox 5"/>
           <p:cNvSpPr txBox="1"/>
           <p:nvPr/>
         </p:nvSpPr>
         <p:spPr>
           <a:xfrm>
-            <a:off x="731520" y="5486400"/>
+            <a:off x="731520" y="5029200"/>
             <a:ext cx="10698480" cy="1280160"/>
           </a:xfrm>
           <a:prstGeom prst="rect">
@@ -3323,14 +3349,14 @@
           <a:lstStyle/>
           <a:p>
             <a:pPr>
-              <a:defRPr sz="1800">
+              <a:defRPr sz="1700">
                 <a:solidFill>
                   <a:srgbClr val="1D3B6E"/>
                 </a:solidFill>
               </a:defRPr>
             </a:pPr>
             <a:r>
-              <a:t>Left: Bahdanau decoder alignment.  Right: Transformer encoder self-attention.  Bright cells = focused source token.</a:t>
+              <a:t>Bahdanau decoder alignment | Transformer encoder self-attention | Transformer decoder cross-attention. Bahdanau and Transformer cross-attention learn visually similar source-to-output alignments.</a:t>
             </a:r>
           </a:p>
         </p:txBody>
@@ -3390,7 +3416,7 @@
       </p:sp>
       <p:pic>
         <p:nvPicPr>
-          <p:cNvPr id="3" name="Picture 2" descr="length_bucketed_compare.png"/>
+          <p:cNvPr id="3" name="Picture 2" descr="three_way_compare.png"/>
           <p:cNvPicPr>
             <a:picLocks noChangeAspect="1"/>
           </p:cNvPicPr>
@@ -3404,8 +3430,8 @@
         </p:blipFill>
         <p:spPr>
           <a:xfrm>
-            <a:off x="2743200" y="1371600"/>
-            <a:ext cx="7040880" cy="4023360"/>
+            <a:off x="3291840" y="1371600"/>
+            <a:ext cx="6217920" cy="3108960"/>
           </a:xfrm>
           <a:prstGeom prst="rect">
             <a:avLst/>
@@ -3420,31 +3446,50 @@
         </p:nvSpPr>
         <p:spPr>
           <a:xfrm>
-            <a:off x="731520" y="5577840"/>
-            <a:ext cx="10698480" cy="1280160"/>
+            <a:off x="731520" y="4663440"/>
+            <a:ext cx="10698480" cy="4572000"/>
           </a:xfrm>
           <a:prstGeom prst="rect">
             <a:avLst/>
           </a:prstGeom>
-          <a:solidFill>
-            <a:srgbClr val="EEF2FB"/>
-          </a:solidFill>
+          <a:noFill/>
         </p:spPr>
         <p:txBody>
-          <a:bodyPr wrap="square" lIns="182880">
+          <a:bodyPr wrap="square">
             <a:spAutoFit/>
           </a:bodyPr>
           <a:lstStyle/>
           <a:p>
             <a:pPr>
-              <a:defRPr sz="1800">
-                <a:solidFill>
-                  <a:srgbClr val="1D3B6E"/>
-                </a:solidFill>
-              </a:defRPr>
-            </a:pPr>
-            <a:r>
-              <a:t>All models do best on short sentences; the bottleneck LSTM degrades fastest as sentences get longer.</a:t>
+              <a:spcAft>
+                <a:spcPts val="800"/>
+              </a:spcAft>
+              <a:defRPr sz="1800"/>
+            </a:pPr>
+            <a:r>
+              <a:t>Bottleneck LSTM (blue) collapses to ~0 on medium/long sentences.</a:t>
+            </a:r>
+          </a:p>
+          <a:p>
+            <a:pPr>
+              <a:spcAft>
+                <a:spcPts val="800"/>
+              </a:spcAft>
+              <a:defRPr sz="1800"/>
+            </a:pPr>
+            <a:r>
+              <a:t>Bahdanau and Transformer stay non-zero - attention prevents the collapse.</a:t>
+            </a:r>
+          </a:p>
+          <a:p>
+            <a:pPr>
+              <a:spcAft>
+                <a:spcPts val="800"/>
+              </a:spcAft>
+              <a:defRPr sz="1800"/>
+            </a:pPr>
+            <a:r>
+              <a:t>Crossover: Transformer (green) overtakes Bahdanau (orange) on the LONG bucket - its O(1) path helps most there.</a:t>
             </a:r>
           </a:p>
         </p:txBody>
@@ -3497,7 +3542,7 @@
               </a:defRPr>
             </a:pPr>
             <a:r>
-              <a:t>Grammar-Rule Analysis of Outputs</a:t>
+              <a:t>Worked Example - The Three Correctors</a:t>
             </a:r>
           </a:p>
         </p:txBody>
@@ -3510,8 +3555,8 @@
         </p:nvSpPr>
         <p:spPr>
           <a:xfrm>
-            <a:off x="731520" y="1371600"/>
-            <a:ext cx="10698480" cy="4572000"/>
+            <a:off x="640080" y="1371600"/>
+            <a:ext cx="10972800" cy="4937760"/>
           </a:xfrm>
           <a:prstGeom prst="rect">
             <a:avLst/>
@@ -3525,79 +3570,116 @@
           <a:lstStyle/>
           <a:p>
             <a:pPr>
-              <a:spcAft>
-                <a:spcPts val="800"/>
-              </a:spcAft>
-              <a:defRPr sz="2200"/>
-            </a:pPr>
-            <a:r>
-              <a:t>Learned well (local syntax):</a:t>
-            </a:r>
-          </a:p>
-          <a:p>
-            <a:pPr lvl="1">
-              <a:spcAft>
-                <a:spcPts val="800"/>
-              </a:spcAft>
-              <a:defRPr sz="1800"/>
-            </a:pPr>
-            <a:r>
-              <a:t>Subject-verb agreement: "What are this job" -&gt; "What is this job"</a:t>
-            </a:r>
-          </a:p>
-          <a:p>
-            <a:pPr lvl="1">
-              <a:spcAft>
-                <a:spcPts val="800"/>
-              </a:spcAft>
-              <a:defRPr sz="1800"/>
-            </a:pPr>
-            <a:r>
-              <a:t>Articles: "Why new record" -&gt; "Why the new record"</a:t>
-            </a:r>
-          </a:p>
-          <a:p>
-            <a:pPr lvl="1">
-              <a:spcAft>
-                <a:spcPts val="800"/>
-              </a:spcAft>
-              <a:defRPr sz="1800"/>
-            </a:pPr>
-            <a:r>
-              <a:t>Verb tense, punctuation, spacing.</a:t>
-            </a:r>
-          </a:p>
-          <a:p>
-            <a:pPr>
-              <a:spcAft>
-                <a:spcPts val="800"/>
-              </a:spcAft>
-              <a:defRPr sz="2200"/>
-            </a:pPr>
-            <a:r>
-              <a:t>Still hard:</a:t>
-            </a:r>
-          </a:p>
-          <a:p>
-            <a:pPr lvl="1">
-              <a:spcAft>
-                <a:spcPts val="800"/>
-              </a:spcAft>
-              <a:defRPr sz="1800"/>
-            </a:pPr>
-            <a:r>
-              <a:t>Long-range / semantic edits; rare-word spelling (hallucination).</a:t>
-            </a:r>
-          </a:p>
-          <a:p>
-            <a:pPr lvl="1">
-              <a:spcAft>
-                <a:spcPts val="800"/>
-              </a:spcAft>
-              <a:defRPr sz="1800"/>
-            </a:pPr>
-            <a:r>
-              <a:t>Dominant failure = under-correction: copying the source unchanged.</a:t>
+              <a:defRPr b="1" sz="1900"/>
+            </a:pPr>
+            <a:r>
+              <a:t>Short sentence (insert a missing article):</a:t>
+            </a:r>
+          </a:p>
+          <a:p>
+            <a:pPr>
+              <a:defRPr b="0" sz="1600">
+                <a:latin typeface="Consolas"/>
+              </a:defRPr>
+            </a:pPr>
+            <a:r>
+              <a:t>SRC : Why new record is taking so long.</a:t>
+            </a:r>
+          </a:p>
+          <a:p>
+            <a:pPr>
+              <a:defRPr b="0" sz="1600">
+                <a:latin typeface="Consolas"/>
+              </a:defRPr>
+            </a:pPr>
+            <a:r>
+              <a:t>REF : Why the new record is taking so long.</a:t>
+            </a:r>
+          </a:p>
+          <a:p>
+            <a:pPr>
+              <a:defRPr b="0" sz="1600">
+                <a:latin typeface="Consolas"/>
+              </a:defRPr>
+            </a:pPr>
+            <a:r>
+              <a:t>P3  : Why new record is taking so long.    LSTM   - no edit (copies)</a:t>
+            </a:r>
+          </a:p>
+          <a:p>
+            <a:pPr>
+              <a:defRPr b="0" sz="1600">
+                <a:latin typeface="Consolas"/>
+              </a:defRPr>
+            </a:pPr>
+            <a:r>
+              <a:t>P4  : Why a new record is taking so long.  Bahd.  - inserts article 'a'</a:t>
+            </a:r>
+          </a:p>
+          <a:p>
+            <a:pPr>
+              <a:defRPr b="0" sz="1600">
+                <a:latin typeface="Consolas"/>
+              </a:defRPr>
+            </a:pPr>
+            <a:r>
+              <a:t>P5  : Why new record is taking so long?    Trans. - '.' -&gt; '?'</a:t>
+            </a:r>
+          </a:p>
+          <a:p>
+            <a:pPr>
+              <a:defRPr b="0" sz="1600"/>
+            </a:pPr>
+          </a:p>
+          <a:p>
+            <a:pPr>
+              <a:defRPr b="1" sz="1900"/>
+            </a:pPr>
+            <a:r>
+              <a:t>Long, noisy sentence:</a:t>
+            </a:r>
+          </a:p>
+          <a:p>
+            <a:pPr>
+              <a:defRPr b="0" sz="1600">
+                <a:latin typeface="Consolas"/>
+              </a:defRPr>
+            </a:pPr>
+            <a:r>
+              <a:t>P3 : '...cpue to buy and/indukine stead...'  hallucinated nonsense</a:t>
+            </a:r>
+          </a:p>
+          <a:p>
+            <a:pPr>
+              <a:defRPr b="0" sz="1600">
+                <a:latin typeface="Consolas"/>
+              </a:defRPr>
+            </a:pPr>
+            <a:r>
+              <a:t>P4 : copies source, corrupts the URL</a:t>
+            </a:r>
+          </a:p>
+          <a:p>
+            <a:pPr>
+              <a:defRPr b="0" sz="1600">
+                <a:latin typeface="Consolas"/>
+              </a:defRPr>
+            </a:pPr>
+            <a:r>
+              <a:t>P5 : copies source, fixes 'got' -&gt; 'get'     the one real fix</a:t>
+            </a:r>
+          </a:p>
+          <a:p>
+            <a:pPr>
+              <a:defRPr b="0" sz="1600"/>
+            </a:pPr>
+          </a:p>
+          <a:p>
+            <a:pPr>
+              <a:defRPr b="1" sz="1900"/>
+            </a:pPr>
+            <a:r>
+              <a:t>LSTM collapses on long input; P4 and P5 differ by only 1-2 tokens.</a:t>
             </a:r>
           </a:p>
         </p:txBody>
@@ -3650,7 +3732,7 @@
               </a:defRPr>
             </a:pPr>
             <a:r>
-              <a:t>The Final Challenge - Dataset Quality</a:t>
+              <a:t>Why Bahdanau LSTM ~ Transformer</a:t>
             </a:r>
           </a:p>
         </p:txBody>
@@ -3684,18 +3766,7 @@
               <a:defRPr sz="2200"/>
             </a:pPr>
             <a:r>
-              <a:t>Why does EVERY model score only ~2% exact match?</a:t>
-            </a:r>
-          </a:p>
-          <a:p>
-            <a:pPr>
-              <a:spcAft>
-                <a:spcPts val="800"/>
-              </a:spcAft>
-              <a:defRPr sz="2200"/>
-            </a:pPr>
-            <a:r>
-              <a:t>Reference quality is the ceiling - not model capacity:</a:t>
+              <a:t>Test GLEU is tied at 0.618. The Transformer matches, not beats:</a:t>
             </a:r>
           </a:p>
           <a:p>
@@ -3706,7 +3777,7 @@
               <a:defRPr sz="1800"/>
             </a:pPr>
             <a:r>
-              <a:t>References are paraphrases: "informed"-&gt;"suggest", "startups"-&gt;"start-ups" - not grammar errors.</a:t>
+              <a:t>Decisive feature is shared - both have full source access via attention (the +0.386 jump). LSTM-vs-self-attention is second-order.</a:t>
             </a:r>
           </a:p>
           <a:p>
@@ -3717,7 +3788,7 @@
               <a:defRPr sz="1800"/>
             </a:pPr>
             <a:r>
-              <a:t>References can be noisy: target "no brain worky" - not a word.</a:t>
+              <a:t>Both hit the data ceiling - same budget, same noisy C4_200M references -&gt; both converge to GLEU ~0.62.</a:t>
             </a:r>
           </a:p>
           <a:p>
@@ -3728,7 +3799,18 @@
               <a:defRPr sz="1800"/>
             </a:pPr>
             <a:r>
-              <a:t>Many valid corrections exist; exact match credits exactly one.</a:t>
+              <a:t>Sentences are mostly short - the O(1) path only helps long-range dependencies (see the crossover).</a:t>
+            </a:r>
+          </a:p>
+          <a:p>
+            <a:pPr lvl="1">
+              <a:spcAft>
+                <a:spcPts val="800"/>
+              </a:spcAft>
+              <a:defRPr sz="1800"/>
+            </a:pPr>
+            <a:r>
+              <a:t>On hard inputs both just copy - outputs differ by 1-2 tokens.</a:t>
             </a:r>
           </a:p>
         </p:txBody>
@@ -3741,7 +3823,7 @@
         </p:nvSpPr>
         <p:spPr>
           <a:xfrm>
-            <a:off x="731520" y="4846320"/>
+            <a:off x="731520" y="4572000"/>
             <a:ext cx="10698480" cy="1280160"/>
           </a:xfrm>
           <a:prstGeom prst="rect">
@@ -3758,14 +3840,14 @@
           <a:lstStyle/>
           <a:p>
             <a:pPr>
-              <a:defRPr sz="1900">
+              <a:defRPr sz="1800">
                 <a:solidFill>
                   <a:srgbClr val="1D3B6E"/>
                 </a:solidFill>
               </a:defRPr>
             </a:pPr>
             <a:r>
-              <a:t>Report GLEU / F0.5, not exact match. Cleaner data would help more than a bigger model.</a:t>
+              <a:t>The real win is efficiency: same quality with 8.05M params vs 29.06M (3.6x fewer) + faster parallel training - it would pull ahead with more data or cleaner references.</a:t>
             </a:r>
           </a:p>
         </p:txBody>
@@ -3818,6 +3900,327 @@
               </a:defRPr>
             </a:pPr>
             <a:r>
+              <a:t>Grammar-Rule Analysis of Outputs</a:t>
+            </a:r>
+          </a:p>
+        </p:txBody>
+      </p:sp>
+      <p:sp>
+        <p:nvSpPr>
+          <p:cNvPr id="3" name="TextBox 2"/>
+          <p:cNvSpPr txBox="1"/>
+          <p:nvPr/>
+        </p:nvSpPr>
+        <p:spPr>
+          <a:xfrm>
+            <a:off x="731520" y="1371600"/>
+            <a:ext cx="10698480" cy="4572000"/>
+          </a:xfrm>
+          <a:prstGeom prst="rect">
+            <a:avLst/>
+          </a:prstGeom>
+          <a:noFill/>
+        </p:spPr>
+        <p:txBody>
+          <a:bodyPr wrap="square">
+            <a:spAutoFit/>
+          </a:bodyPr>
+          <a:lstStyle/>
+          <a:p>
+            <a:pPr>
+              <a:spcAft>
+                <a:spcPts val="800"/>
+              </a:spcAft>
+              <a:defRPr sz="2200"/>
+            </a:pPr>
+            <a:r>
+              <a:t>Learned well (local syntax):</a:t>
+            </a:r>
+          </a:p>
+          <a:p>
+            <a:pPr lvl="1">
+              <a:spcAft>
+                <a:spcPts val="800"/>
+              </a:spcAft>
+              <a:defRPr sz="1800"/>
+            </a:pPr>
+            <a:r>
+              <a:t>Subject-verb agreement: "What are this job" -&gt; "What is this job"</a:t>
+            </a:r>
+          </a:p>
+          <a:p>
+            <a:pPr lvl="1">
+              <a:spcAft>
+                <a:spcPts val="800"/>
+              </a:spcAft>
+              <a:defRPr sz="1800"/>
+            </a:pPr>
+            <a:r>
+              <a:t>Articles: "Why new record" -&gt; "Why the new record"</a:t>
+            </a:r>
+          </a:p>
+          <a:p>
+            <a:pPr lvl="1">
+              <a:spcAft>
+                <a:spcPts val="800"/>
+              </a:spcAft>
+              <a:defRPr sz="1800"/>
+            </a:pPr>
+            <a:r>
+              <a:t>Verb tense, punctuation, spacing.</a:t>
+            </a:r>
+          </a:p>
+          <a:p>
+            <a:pPr>
+              <a:spcAft>
+                <a:spcPts val="800"/>
+              </a:spcAft>
+              <a:defRPr sz="2200"/>
+            </a:pPr>
+            <a:r>
+              <a:t>Still hard:</a:t>
+            </a:r>
+          </a:p>
+          <a:p>
+            <a:pPr lvl="1">
+              <a:spcAft>
+                <a:spcPts val="800"/>
+              </a:spcAft>
+              <a:defRPr sz="1800"/>
+            </a:pPr>
+            <a:r>
+              <a:t>Long-range / semantic edits; rare-word spelling (hallucination).</a:t>
+            </a:r>
+          </a:p>
+          <a:p>
+            <a:pPr lvl="1">
+              <a:spcAft>
+                <a:spcPts val="800"/>
+              </a:spcAft>
+              <a:defRPr sz="1800"/>
+            </a:pPr>
+            <a:r>
+              <a:t>Dominant failure = under-correction: copying the source unchanged.</a:t>
+            </a:r>
+          </a:p>
+        </p:txBody>
+      </p:sp>
+    </p:spTree>
+  </p:cSld>
+  <p:clrMapOvr>
+    <a:masterClrMapping/>
+  </p:clrMapOvr>
+</p:sld>
+</file>
+
+<file path=ppt/slides/slide15.xml><?xml version="1.0" encoding="utf-8"?>
+<p:sld xmlns:a="http://schemas.openxmlformats.org/drawingml/2006/main" xmlns:p="http://schemas.openxmlformats.org/presentationml/2006/main" xmlns:r="http://schemas.openxmlformats.org/officeDocument/2006/relationships">
+  <p:cSld>
+    <p:spTree>
+      <p:nvGrpSpPr>
+        <p:cNvPr id="1" name=""/>
+        <p:cNvGrpSpPr/>
+        <p:nvPr/>
+      </p:nvGrpSpPr>
+      <p:grpSpPr/>
+      <p:sp>
+        <p:nvSpPr>
+          <p:cNvPr id="2" name="TextBox 1"/>
+          <p:cNvSpPr txBox="1"/>
+          <p:nvPr/>
+        </p:nvSpPr>
+        <p:spPr>
+          <a:xfrm>
+            <a:off x="548640" y="320040"/>
+            <a:ext cx="11064240" cy="822960"/>
+          </a:xfrm>
+          <a:prstGeom prst="rect">
+            <a:avLst/>
+          </a:prstGeom>
+          <a:noFill/>
+        </p:spPr>
+        <p:txBody>
+          <a:bodyPr wrap="square">
+            <a:spAutoFit/>
+          </a:bodyPr>
+          <a:lstStyle/>
+          <a:p>
+            <a:pPr>
+              <a:defRPr sz="3200" b="1">
+                <a:solidFill>
+                  <a:srgbClr val="1D3B6E"/>
+                </a:solidFill>
+              </a:defRPr>
+            </a:pPr>
+            <a:r>
+              <a:t>The Final Challenge - Dataset Quality</a:t>
+            </a:r>
+          </a:p>
+        </p:txBody>
+      </p:sp>
+      <p:sp>
+        <p:nvSpPr>
+          <p:cNvPr id="3" name="TextBox 2"/>
+          <p:cNvSpPr txBox="1"/>
+          <p:nvPr/>
+        </p:nvSpPr>
+        <p:spPr>
+          <a:xfrm>
+            <a:off x="731520" y="1371600"/>
+            <a:ext cx="10698480" cy="4572000"/>
+          </a:xfrm>
+          <a:prstGeom prst="rect">
+            <a:avLst/>
+          </a:prstGeom>
+          <a:noFill/>
+        </p:spPr>
+        <p:txBody>
+          <a:bodyPr wrap="square">
+            <a:spAutoFit/>
+          </a:bodyPr>
+          <a:lstStyle/>
+          <a:p>
+            <a:pPr>
+              <a:spcAft>
+                <a:spcPts val="800"/>
+              </a:spcAft>
+              <a:defRPr sz="2200"/>
+            </a:pPr>
+            <a:r>
+              <a:t>Why does EVERY model score only ~2% exact match?</a:t>
+            </a:r>
+          </a:p>
+          <a:p>
+            <a:pPr>
+              <a:spcAft>
+                <a:spcPts val="800"/>
+              </a:spcAft>
+              <a:defRPr sz="2200"/>
+            </a:pPr>
+            <a:r>
+              <a:t>Reference quality is the ceiling - not model capacity:</a:t>
+            </a:r>
+          </a:p>
+          <a:p>
+            <a:pPr lvl="1">
+              <a:spcAft>
+                <a:spcPts val="800"/>
+              </a:spcAft>
+              <a:defRPr sz="1800"/>
+            </a:pPr>
+            <a:r>
+              <a:t>References are paraphrases: "informed"-&gt;"suggest", "startups"-&gt;"start-ups" - not grammar errors.</a:t>
+            </a:r>
+          </a:p>
+          <a:p>
+            <a:pPr lvl="1">
+              <a:spcAft>
+                <a:spcPts val="800"/>
+              </a:spcAft>
+              <a:defRPr sz="1800"/>
+            </a:pPr>
+            <a:r>
+              <a:t>References can be noisy: target "no brain worky" - not a word.</a:t>
+            </a:r>
+          </a:p>
+          <a:p>
+            <a:pPr lvl="1">
+              <a:spcAft>
+                <a:spcPts val="800"/>
+              </a:spcAft>
+              <a:defRPr sz="1800"/>
+            </a:pPr>
+            <a:r>
+              <a:t>Many valid corrections exist; exact match credits exactly one.</a:t>
+            </a:r>
+          </a:p>
+        </p:txBody>
+      </p:sp>
+      <p:sp>
+        <p:nvSpPr>
+          <p:cNvPr id="4" name="TextBox 3"/>
+          <p:cNvSpPr txBox="1"/>
+          <p:nvPr/>
+        </p:nvSpPr>
+        <p:spPr>
+          <a:xfrm>
+            <a:off x="731520" y="4846320"/>
+            <a:ext cx="10698480" cy="1280160"/>
+          </a:xfrm>
+          <a:prstGeom prst="rect">
+            <a:avLst/>
+          </a:prstGeom>
+          <a:solidFill>
+            <a:srgbClr val="EEF2FB"/>
+          </a:solidFill>
+        </p:spPr>
+        <p:txBody>
+          <a:bodyPr wrap="square" lIns="182880">
+            <a:spAutoFit/>
+          </a:bodyPr>
+          <a:lstStyle/>
+          <a:p>
+            <a:pPr>
+              <a:defRPr sz="1900">
+                <a:solidFill>
+                  <a:srgbClr val="1D3B6E"/>
+                </a:solidFill>
+              </a:defRPr>
+            </a:pPr>
+            <a:r>
+              <a:t>Report GLEU / F0.5, not exact match. Cleaner data would help more than a bigger model.</a:t>
+            </a:r>
+          </a:p>
+        </p:txBody>
+      </p:sp>
+    </p:spTree>
+  </p:cSld>
+  <p:clrMapOvr>
+    <a:masterClrMapping/>
+  </p:clrMapOvr>
+</p:sld>
+</file>
+
+<file path=ppt/slides/slide16.xml><?xml version="1.0" encoding="utf-8"?>
+<p:sld xmlns:a="http://schemas.openxmlformats.org/drawingml/2006/main" xmlns:p="http://schemas.openxmlformats.org/presentationml/2006/main" xmlns:r="http://schemas.openxmlformats.org/officeDocument/2006/relationships">
+  <p:cSld>
+    <p:spTree>
+      <p:nvGrpSpPr>
+        <p:cNvPr id="1" name=""/>
+        <p:cNvGrpSpPr/>
+        <p:nvPr/>
+      </p:nvGrpSpPr>
+      <p:grpSpPr/>
+      <p:sp>
+        <p:nvSpPr>
+          <p:cNvPr id="2" name="TextBox 1"/>
+          <p:cNvSpPr txBox="1"/>
+          <p:nvPr/>
+        </p:nvSpPr>
+        <p:spPr>
+          <a:xfrm>
+            <a:off x="548640" y="320040"/>
+            <a:ext cx="11064240" cy="822960"/>
+          </a:xfrm>
+          <a:prstGeom prst="rect">
+            <a:avLst/>
+          </a:prstGeom>
+          <a:noFill/>
+        </p:spPr>
+        <p:txBody>
+          <a:bodyPr wrap="square">
+            <a:spAutoFit/>
+          </a:bodyPr>
+          <a:lstStyle/>
+          <a:p>
+            <a:pPr>
+              <a:defRPr sz="3200" b="1">
+                <a:solidFill>
+                  <a:srgbClr val="1D3B6E"/>
+                </a:solidFill>
+              </a:defRPr>
+            </a:pPr>
+            <a:r>
               <a:t>Conclusion</a:t>
             </a:r>
           </a:p>
@@ -3935,7 +4338,7 @@
 </p:sld>
 </file>
 
-<file path=ppt/slides/slide15.xml><?xml version="1.0" encoding="utf-8"?>
+<file path=ppt/slides/slide17.xml><?xml version="1.0" encoding="utf-8"?>
 <p:sld xmlns:a="http://schemas.openxmlformats.org/drawingml/2006/main" xmlns:p="http://schemas.openxmlformats.org/presentationml/2006/main" xmlns:r="http://schemas.openxmlformats.org/officeDocument/2006/relationships">
   <p:cSld>
     <p:spTree>
@@ -4716,7 +5119,7 @@
               <a:defRPr sz="2200"/>
             </a:pPr>
             <a:r>
-              <a:t>Each pair -&gt; two samples: corrupted = ungrammatical (0), clean = grammatical (1).</a:t>
+              <a:t>TF-IDF (unigrams+bigrams, 50k vocab) + Logistic Regression / Linear SVM. Each pair -&gt; corrupted = 0, clean = 1.</a:t>
             </a:r>
           </a:p>
           <a:p>
@@ -4727,18 +5130,51 @@
               <a:defRPr sz="2200"/>
             </a:pPr>
             <a:r>
-              <a:t>Features: TF-IDF, unigrams + bigrams, 50k vocab (fit on train only).</a:t>
-            </a:r>
-          </a:p>
-          <a:p>
-            <a:pPr>
+              <a:t>Result: ~62% accuracy - barely above 50% chance. Why so weak? Structural, not bad tuning:</a:t>
+            </a:r>
+          </a:p>
+          <a:p>
+            <a:pPr lvl="1">
               <a:spcAft>
                 <a:spcPts val="800"/>
               </a:spcAft>
-              <a:defRPr sz="2200"/>
-            </a:pPr>
-            <a:r>
-              <a:t>Classifiers: Logistic Regression and Linear SVM.</a:t>
+              <a:defRPr sz="1800"/>
+            </a:pPr>
+            <a:r>
+              <a:t>Detector, not corrector - outputs one label, never corrected text.</a:t>
+            </a:r>
+          </a:p>
+          <a:p>
+            <a:pPr lvl="1">
+              <a:spcAft>
+                <a:spcPts val="800"/>
+              </a:spcAft>
+              <a:defRPr sz="1800"/>
+            </a:pPr>
+            <a:r>
+              <a:t>Bag-of-words discards order - but grammar IS order ("she goes" vs "go she").</a:t>
+            </a:r>
+          </a:p>
+          <a:p>
+            <a:pPr lvl="1">
+              <a:spcAft>
+                <a:spcPts val="800"/>
+              </a:spcAft>
+              <a:defRPr sz="1800"/>
+            </a:pPr>
+            <a:r>
+              <a:t>Error signal swamped - a 1-word error is invisible next to content-word weights.</a:t>
+            </a:r>
+          </a:p>
+          <a:p>
+            <a:pPr lvl="1">
+              <a:spcAft>
+                <a:spcPts val="800"/>
+              </a:spcAft>
+              <a:defRPr sz="1800"/>
+            </a:pPr>
+            <a:r>
+              <a:t>No generalisation - only memorises lexical statistics.</a:t>
             </a:r>
           </a:p>
         </p:txBody>
@@ -4751,7 +5187,7 @@
         </p:nvSpPr>
         <p:spPr>
           <a:xfrm>
-            <a:off x="731520" y="4206240"/>
+            <a:off x="731520" y="4846320"/>
             <a:ext cx="10698480" cy="1280160"/>
           </a:xfrm>
           <a:prstGeom prst="rect">
@@ -4768,14 +5204,14 @@
           <a:lstStyle/>
           <a:p>
             <a:pPr>
-              <a:defRPr sz="2000">
+              <a:defRPr sz="1800">
                 <a:solidFill>
                   <a:srgbClr val="1D3B6E"/>
                 </a:solidFill>
               </a:defRPr>
             </a:pPr>
             <a:r>
-              <a:t>Result: ~62% detection accuracy - barely above 50% chance. Surface word statistics cannot solve GEC -&gt; need seq2seq.</a:t>
+              <a:t>Proves GEC needs sequence modelling and text generation - which the next three models provide.</a:t>
             </a:r>
           </a:p>
         </p:txBody>

</xml_diff>